<commit_message>
Week 4 Poster FINAL - All Ikeda requirements met
</commit_message>
<xml_diff>
--- a/poster/NGUYENHOANG_Poster.pptx
+++ b/poster/NGUYENHOANG_Poster.pptx
@@ -11950,8 +11950,8 @@
         </p:nvSpPr>
         <p:spPr>
           <a:xfrm>
-            <a:off x="10978515" y="17100550"/>
-            <a:ext cx="10224135" cy="3288030"/>
+            <a:off x="10981055" y="17158970"/>
+            <a:ext cx="10224135" cy="3018790"/>
           </a:xfrm>
           <a:prstGeom prst="rect">
             <a:avLst/>
@@ -12229,7 +12229,7 @@
         </p:nvSpPr>
         <p:spPr>
           <a:xfrm>
-            <a:off x="360295" y="20424884"/>
+            <a:off x="885" y="20424884"/>
             <a:ext cx="20520000" cy="705485"/>
           </a:xfrm>
           <a:prstGeom prst="rect">
@@ -12287,8 +12287,8 @@
         </p:nvSpPr>
         <p:spPr>
           <a:xfrm>
-            <a:off x="360045" y="21026120"/>
-            <a:ext cx="9719945" cy="2341880"/>
+            <a:off x="-1905" y="21275675"/>
+            <a:ext cx="13648690" cy="3245485"/>
           </a:xfrm>
           <a:prstGeom prst="rect">
             <a:avLst/>
@@ -12357,26 +12357,6 @@
               </a:rPr>
               <a:t>DP (Demographic Parity)</a:t>
             </a:r>
-            <a:endParaRPr lang="en-US" sz="3600" b="1" i="0" u="none" strike="noStrike" cap="none">
-              <a:solidFill>
-                <a:schemeClr val="dk1"/>
-              </a:solidFill>
-              <a:latin typeface="Calibri" panose="020F0502020204030204"/>
-              <a:ea typeface="Calibri" panose="020F0502020204030204"/>
-              <a:cs typeface="Calibri" panose="020F0502020204030204"/>
-              <a:sym typeface="Calibri" panose="020F0502020204030204"/>
-            </a:endParaRPr>
-          </a:p>
-          <a:p>
-            <a:pPr marL="0" marR="0" lvl="0" indent="0" algn="l" rtl="0">
-              <a:spcBef>
-                <a:spcPts val="400"/>
-              </a:spcBef>
-              <a:spcAft>
-                <a:spcPts val="0"/>
-              </a:spcAft>
-              <a:buNone/>
-            </a:pPr>
             <a:r>
               <a:rPr lang="en-US" sz="3600" b="0" i="0" u="none" strike="noStrike" cap="none">
                 <a:solidFill>
@@ -12387,7 +12367,7 @@
                 <a:cs typeface="Calibri" panose="020F0502020204030204"/>
                 <a:sym typeface="Calibri" panose="020F0502020204030204"/>
               </a:rPr>
-              <a:t>  承認率の差: |P(Ŷ=1|A=0) − P(Ŷ=1|A=1)|</a:t>
+              <a:t>承認率の差: |P(Ŷ=1|A=0)P(Ŷ=1|A=1)|</a:t>
             </a:r>
             <a:endParaRPr lang="en-US" sz="3600" b="0" i="0" u="none" strike="noStrike" cap="none">
               <a:solidFill>
@@ -12421,26 +12401,6 @@
               </a:rPr>
               <a:t>EO (Equal Opportunity)</a:t>
             </a:r>
-            <a:endParaRPr lang="en-US" sz="3600" b="1" i="0" u="none" strike="noStrike" cap="none">
-              <a:solidFill>
-                <a:schemeClr val="dk1"/>
-              </a:solidFill>
-              <a:latin typeface="Calibri" panose="020F0502020204030204"/>
-              <a:ea typeface="Calibri" panose="020F0502020204030204"/>
-              <a:cs typeface="Calibri" panose="020F0502020204030204"/>
-              <a:sym typeface="Calibri" panose="020F0502020204030204"/>
-            </a:endParaRPr>
-          </a:p>
-          <a:p>
-            <a:pPr marL="0" marR="0" lvl="0" indent="0" algn="l" rtl="0">
-              <a:spcBef>
-                <a:spcPts val="400"/>
-              </a:spcBef>
-              <a:spcAft>
-                <a:spcPts val="0"/>
-              </a:spcAft>
-              <a:buNone/>
-            </a:pPr>
             <a:r>
               <a:rPr lang="en-US" sz="3600" b="0" i="0" u="none" strike="noStrike" cap="none">
                 <a:solidFill>
@@ -12451,7 +12411,7 @@
                 <a:cs typeface="Calibri" panose="020F0502020204030204"/>
                 <a:sym typeface="Calibri" panose="020F0502020204030204"/>
               </a:rPr>
-              <a:t>  真陽性率の差: |TPR(A=0) − TPR(A=1)|</a:t>
+              <a:t>真陽性率の差: |TPR(A=0) − TPR(A=1)|</a:t>
             </a:r>
             <a:endParaRPr lang="en-US" sz="3600" b="0" i="0" u="none" strike="noStrike" cap="none">
               <a:solidFill>
@@ -12473,8 +12433,8 @@
         </p:nvSpPr>
         <p:spPr>
           <a:xfrm>
-            <a:off x="10440035" y="20436205"/>
-            <a:ext cx="9719945" cy="2110740"/>
+            <a:off x="12531090" y="20436205"/>
+            <a:ext cx="10278110" cy="2110740"/>
           </a:xfrm>
           <a:prstGeom prst="rect">
             <a:avLst/>
@@ -13532,7 +13492,7 @@
       </p:sp>
       <p:pic>
         <p:nvPicPr>
-          <p:cNvPr id="1" name="図形 0" descr="fig1_accuracy_vs_fairness"/>
+          <p:cNvPr id="3" name="図形 2" descr="fig1_accuracy_vs_fairness"/>
           <p:cNvPicPr>
             <a:picLocks noChangeAspect="1"/>
           </p:cNvPicPr>
@@ -13570,8 +13530,8 @@
         </p:blipFill>
         <p:spPr>
           <a:xfrm>
-            <a:off x="10981055" y="10417175"/>
-            <a:ext cx="10403205" cy="6751320"/>
+            <a:off x="10978515" y="10417175"/>
+            <a:ext cx="10405745" cy="6751320"/>
           </a:xfrm>
           <a:prstGeom prst="rect">
             <a:avLst/>

</xml_diff>